<commit_message>
docs(antislop): audit and refactor slide, module, pptx, and script copy for human clarity
</commit_message>
<xml_diff>
--- a/presentations/Materi_Pengayaan_Stored_Procedure_UDF_Cursor.pptx
+++ b/presentations/Materi_Pengayaan_Stored_Procedure_UDF_Cursor.pptx
@@ -11423,7 +11423,7 @@
               </a:defRPr>
             </a:pPr>
             <a:r>
-              <a:t>● 01 · ARSITEKTUR RUTIN</a:t>
+              <a:t>● 01 · KONSEPSI &amp; ARSITEKTUR</a:t>
             </a:r>
           </a:p>
         </p:txBody>
@@ -11459,7 +11459,7 @@
               </a:defRPr>
             </a:pPr>
             <a:r>
-              <a:t>Efisiensi Jaringan &amp; Kompilasi RDBMS</a:t>
+              <a:t>Keuntungan Stored Routine</a:t>
             </a:r>
           </a:p>
         </p:txBody>
@@ -11493,7 +11493,7 @@
                 </a:solidFill>
                 <a:latin typeface="Plus Jakarta Sans"/>
               </a:rPr>
-              <a:t>Mengapa Memindahkan Logika ke Sisi Server? </a:t>
+              <a:t>Kenapa Menaruh Logika Bisnis di Database? </a:t>
             </a:r>
             <a:r>
               <a:rPr sz="2100" b="1">
@@ -11502,7 +11502,7 @@
                 </a:solidFill>
                 <a:latin typeface="Plus Jakarta Sans"/>
               </a:rPr>
-              <a:t>Efisiensi Jaringan &amp; Kompilasi RDBMS</a:t>
+              <a:t>Hemat Jaringan &amp; Keamanan Data</a:t>
             </a:r>
           </a:p>
         </p:txBody>
@@ -11574,7 +11574,7 @@
               </a:defRPr>
             </a:pPr>
             <a:r>
-              <a:t>Stored Routine memindahkan beban eksekusi logika bisnis dari aplikasi klien langsung ke memori database engine, memberikan 4 keuntungan fundamental:</a:t>
+              <a:t>Memindahkan logika transaksi langsung ke dalam database engine memberikan 4 keuntungan praktis:</a:t>
             </a:r>
           </a:p>
         </p:txBody>
@@ -11662,7 +11662,7 @@
                 </a:solidFill>
                 <a:latin typeface="Plus Jakarta Sans"/>
               </a:rPr>
-              <a:t>Reduksi Latensi</a:t>
+              <a:t>Hemat Jaringan</a:t>
             </a:r>
           </a:p>
           <a:p>
@@ -11678,7 +11678,7 @@
                 </a:solidFill>
                 <a:latin typeface="Inter"/>
               </a:rPr>
-              <a:t>Menggantikan belasan kueri SELECT dan UPDATE bolak-balik jaringan menjadi satu perintah CALL, memangkas network latency secara drastis.</a:t>
+              <a:t>Aplikasi kasir cukup kirim 1 perintah CALL, bukan bolak-balik kirim belasan kueri lewat jaringan WiFi/kabel.</a:t>
             </a:r>
           </a:p>
         </p:txBody>
@@ -11766,7 +11766,7 @@
                 </a:solidFill>
                 <a:latin typeface="Plus Jakarta Sans"/>
               </a:rPr>
-              <a:t>Logika Terpusat</a:t>
+              <a:t>Aturan Terpusat</a:t>
             </a:r>
           </a:p>
           <a:p>
@@ -11782,7 +11782,7 @@
                 </a:solidFill>
                 <a:latin typeface="Inter"/>
               </a:rPr>
-              <a:t>Formula bisnis (diskon, aturan poin member, batas stok) didefinisikan satu kali di database; seluruh aplikasi kasir menggunakan aturan seragam.</a:t>
+              <a:t>Rumus diskon, batas stok, dan poin ditulis sekali di database. Seluruh aplikasi kasir memakai aturan yang sama.</a:t>
             </a:r>
           </a:p>
         </p:txBody>
@@ -11870,7 +11870,7 @@
                 </a:solidFill>
                 <a:latin typeface="Plus Jakarta Sans"/>
               </a:rPr>
-              <a:t>Execution Cache</a:t>
+              <a:t>Eksekusi Cepat</a:t>
             </a:r>
           </a:p>
           <a:p>
@@ -11886,7 +11886,7 @@
                 </a:solidFill>
                 <a:latin typeface="Inter"/>
               </a:rPr>
-              <a:t>Rencana eksekusi (*execution plan*) dikompilasi satu kali dan disimpan di memori buffer RDBMS. Eksekusi berikutnya berjalan instan tanpa parsing kueri ulang.</a:t>
+              <a:t>Rencana eksekusi (execution plan) disimpan di buffer memori database. Eksekusi berikutnya berjalan langsung tanpa parsing ulang.</a:t>
             </a:r>
           </a:p>
         </p:txBody>
@@ -11974,7 +11974,7 @@
                 </a:solidFill>
                 <a:latin typeface="Plus Jakarta Sans"/>
               </a:rPr>
-              <a:t>Isolasi Izin Akses</a:t>
+              <a:t>Akses Lebih Aman</a:t>
             </a:r>
           </a:p>
           <a:p>
@@ -11990,7 +11990,7 @@
                 </a:solidFill>
                 <a:latin typeface="Inter"/>
               </a:rPr>
-              <a:t>Kasir cukup diberi izin EXECUTE pada procedure penjualan tanpa diberi izin langsung mengubah tabel master produk dan kasir fisik.</a:t>
+              <a:t>Kasir cukup diberi izin EXECUTE pada prosedur penjualan tanpa diberi izin mengubah tabel master fisik secara langsung.</a:t>
             </a:r>
           </a:p>
         </p:txBody>
@@ -12132,7 +12132,7 @@
               </a:defRPr>
             </a:pPr>
             <a:r>
-              <a:t>● 02 · KOMPARASI HAKIKI</a:t>
+              <a:t>● 02 · KOMPARASI LOGIKA</a:t>
             </a:r>
           </a:p>
         </p:txBody>
@@ -12168,7 +12168,7 @@
               </a:defRPr>
             </a:pPr>
             <a:r>
-              <a:t>Stored Function vs Stored Procedure</a:t>
+              <a:t>Function vs Procedure</a:t>
             </a:r>
           </a:p>
         </p:txBody>
@@ -12202,7 +12202,7 @@
                 </a:solidFill>
                 <a:latin typeface="Plus Jakarta Sans"/>
               </a:rPr>
-              <a:t>Perbedaan Hakiki: Function vs Procedure </a:t>
+              <a:t>Perbedaan Utama: Function vs Procedure </a:t>
             </a:r>
             <a:r>
               <a:rPr sz="2100" b="1">
@@ -12211,7 +12211,7 @@
                 </a:solidFill>
                 <a:latin typeface="Plus Jakarta Sans"/>
               </a:rPr>
-              <a:t>Batasan Arsitektural</a:t>
+              <a:t>Kriteria &amp; Batasan</a:t>
             </a:r>
           </a:p>
         </p:txBody>
@@ -12283,7 +12283,7 @@
               </a:defRPr>
             </a:pPr>
             <a:r>
-              <a:t>Meskipun sama-sama blok kode terkompilasi, keduanya memiliki batasan arsitektural dan tujuan penggunaan yang sangat berbeda:</a:t>
+              <a:t>Meskipun sama-sama blok kode di sisi server, keduanya dirancang untuk tugas yang berbeda:</a:t>
             </a:r>
           </a:p>
         </p:txBody>
@@ -12325,7 +12325,7 @@
                           </a:solidFill>
                           <a:latin typeface="Plus Jakarta Sans"/>
                         </a:rPr>
-                        <a:t>Parameter Karakteristik</a:t>
+                        <a:t>Kriteria</a:t>
                       </a:r>
                     </a:p>
                   </a:txBody>
@@ -12396,7 +12396,7 @@
                           </a:solidFill>
                           <a:latin typeface="Inter"/>
                         </a:rPr>
-                        <a:t>Nilai Kembalian (Return)</a:t>
+                        <a:t>Nilai Kembalian</a:t>
                       </a:r>
                     </a:p>
                   </a:txBody>
@@ -12442,7 +12442,7 @@
                           </a:solidFill>
                           <a:latin typeface="Inter"/>
                         </a:rPr>
-                        <a:t>Tidak memiliki return langsung; lewat parameter OUT / INOUT / result set.</a:t>
+                        <a:t>Tidak ada return langsung; memakai parameter OUT / INOUT.</a:t>
                       </a:r>
                     </a:p>
                   </a:txBody>
@@ -12467,7 +12467,7 @@
                           </a:solidFill>
                           <a:latin typeface="Inter"/>
                         </a:rPr>
-                        <a:t>Metode Pemanggilan</a:t>
+                        <a:t>Cara Panggil</a:t>
                       </a:r>
                     </a:p>
                   </a:txBody>
@@ -12490,7 +12490,7 @@
                           </a:solidFill>
                           <a:latin typeface="Inter"/>
                         </a:rPr>
-                        <a:t>Dipanggil di dalam ekspresi kueri SQL biasa (SELECT fc(), WHERE fc() &gt; 0).</a:t>
+                        <a:t>Dipanggil di dalam kueri SQL biasa (SELECT fc(), WHERE fc() &gt; 0).</a:t>
                       </a:r>
                     </a:p>
                   </a:txBody>
@@ -12513,7 +12513,7 @@
                           </a:solidFill>
                           <a:latin typeface="Inter"/>
                         </a:rPr>
-                        <a:t>Dipanggil secara mandiri sebagai perintah terpisah: CALL sp_name(argumen);.</a:t>
+                        <a:t>Dipanggil terpisah sebagai perintah mandiri: CALL sp_name(argumen);.</a:t>
                       </a:r>
                     </a:p>
                   </a:txBody>
@@ -12538,7 +12538,7 @@
                           </a:solidFill>
                           <a:latin typeface="Inter"/>
                         </a:rPr>
-                        <a:t>Manipulasi Fisik (DML)</a:t>
+                        <a:t>Ubah Data (DML)</a:t>
                       </a:r>
                     </a:p>
                   </a:txBody>
@@ -12561,7 +12561,7 @@
                           </a:solidFill>
                           <a:latin typeface="Inter"/>
                         </a:rPr>
-                        <a:t>Sangat dibatasi; dilarang mengubah state tabel (INSERT/UPDATE/DELETE) pada kueri baca.</a:t>
+                        <a:t>Dilarang mengubah isi tabel saat dipanggil kueri baca.</a:t>
                       </a:r>
                     </a:p>
                   </a:txBody>
@@ -12584,7 +12584,7 @@
                           </a:solidFill>
                           <a:latin typeface="Inter"/>
                         </a:rPr>
-                        <a:t>Bebas DML penuh; dapat memutasi data, transaksi COMMIT/ROLLBACK, dan dynamic SQL.</a:t>
+                        <a:t>Bebas mengubah data, mengontrol transaksi COMMIT/ROLLBACK, dan kueri dinamis.</a:t>
                       </a:r>
                     </a:p>
                   </a:txBody>
@@ -12609,7 +12609,7 @@
                           </a:solidFill>
                           <a:latin typeface="Inter"/>
                         </a:rPr>
-                        <a:t>Fokus Penggunaan</a:t>
+                        <a:t>Kapan Dipakai</a:t>
                       </a:r>
                     </a:p>
                   </a:txBody>
@@ -12632,7 +12632,7 @@
                           </a:solidFill>
                           <a:latin typeface="Inter"/>
                         </a:rPr>
-                        <a:t>Kalkulasi skalar, format teks, konversi mata uang, atau generator kode unik.</a:t>
+                        <a:t>Perhitungan skalar, format teks, konversi nilai, atau nomor urut nota.</a:t>
                       </a:r>
                     </a:p>
                   </a:txBody>
@@ -12655,7 +12655,7 @@
                           </a:solidFill>
                           <a:latin typeface="Inter"/>
                         </a:rPr>
-                        <a:t>Alur kerja transaksi multi-tabel, batch processing berkala, dan otomasi checkout kasir.</a:t>
+                        <a:t>Alur transaksi multi-tabel, batch processing berkala, dan otomasi kasir.</a:t>
                       </a:r>
                     </a:p>
                   </a:txBody>
@@ -12843,7 +12843,7 @@
               </a:defRPr>
             </a:pPr>
             <a:r>
-              <a:t>Fungsi Skalar Sisi Server</a:t>
+              <a:t>Fungsi Buatan Sendiri</a:t>
             </a:r>
           </a:p>
         </p:txBody>
@@ -12877,7 +12877,7 @@
                 </a:solidFill>
                 <a:latin typeface="Plus Jakarta Sans"/>
               </a:rPr>
-              <a:t>Anatomi &amp; Karakteristik User Defined Function </a:t>
+              <a:t>User Defined Function &amp; Karakteristik Sifat </a:t>
             </a:r>
             <a:r>
               <a:rPr sz="2100" b="1">
@@ -12886,7 +12886,7 @@
                 </a:solidFill>
                 <a:latin typeface="Plus Jakarta Sans"/>
               </a:rPr>
-              <a:t>Logika Skalar</a:t>
+              <a:t>Nilai Kembalian Tunggal</a:t>
             </a:r>
           </a:p>
         </p:txBody>
@@ -15111,7 +15111,7 @@
                 </a:solidFill>
                 <a:latin typeface="Plus Jakarta Sans"/>
               </a:rPr>
-              <a:t>IN (Input Param)</a:t>
+              <a:t>IN (Input Saja)</a:t>
             </a:r>
           </a:p>
           <a:p>
@@ -15127,7 +15127,7 @@
                 </a:solidFill>
                 <a:latin typeface="Inter"/>
               </a:rPr>
-              <a:t>Bersifat Pass-by-Value (read-only). Nilai dikirim oleh pemanggil ke dalam prosedur. Perubahan variabel lokal di dalam prosedur tidak mengubah nilai pemanggil.</a:t>
+              <a:t>Nilai dikirim oleh pemanggil ke dalam prosedur. Perubahan nilai di dalam prosedur tidak mengubah variabel di luar (read-only).</a:t>
             </a:r>
           </a:p>
         </p:txBody>
@@ -15215,7 +15215,7 @@
                 </a:solidFill>
                 <a:latin typeface="Plus Jakarta Sans"/>
               </a:rPr>
-              <a:t>OUT (Output Param)</a:t>
+              <a:t>OUT (Keluaran Saja)</a:t>
             </a:r>
           </a:p>
           <a:p>
@@ -15231,7 +15231,7 @@
                 </a:solidFill>
                 <a:latin typeface="Inter"/>
               </a:rPr>
-              <a:t>Bersifat Pass-by-Reference (write-only). Nilai awal diabaikan (NULL). Prosedur mengisi nilai, dan pemanggil dapat membacanya setelah prosedur selesai.</a:t>
+              <a:t>Nilai awalnya kosong (NULL). Prosedur mengisi nilai hasil perhitungan, lalu dikembalikan ke variabel pemanggil.</a:t>
             </a:r>
           </a:p>
         </p:txBody>
@@ -15319,7 +15319,7 @@
                 </a:solidFill>
                 <a:latin typeface="Plus Jakarta Sans"/>
               </a:rPr>
-              <a:t>INOUT (Dual Param)</a:t>
+              <a:t>INOUT (Bolak-Balik)</a:t>
             </a:r>
           </a:p>
           <a:p>
@@ -15335,7 +15335,7 @@
                 </a:solidFill>
                 <a:latin typeface="Inter"/>
               </a:rPr>
-              <a:t>Bersifat Dua Arah (read-write). Pemanggil mengirimkan nilai awal, lalu prosedur memproses dan mengubah nilai tersebut kembali ke pemanggil.</a:t>
+              <a:t>Membawa nilai awal dari luar, diproses atau dimodifikasi di dalam prosedur, lalu nilai barunya dikembalikan lagi.</a:t>
             </a:r>
           </a:p>
         </p:txBody>
@@ -16604,7 +16604,7 @@
               </a:defRPr>
             </a:pPr>
             <a:r>
-              <a:t>● 05 · CONTROL FLOW</a:t>
+              <a:t>● 05 · KONTROL ALUR</a:t>
             </a:r>
           </a:p>
         </p:txBody>
@@ -16674,7 +16674,7 @@
                 </a:solidFill>
                 <a:latin typeface="Plus Jakarta Sans"/>
               </a:rPr>
-              <a:t>Struktur Kontrol Alur Logika di MySQL </a:t>
+              <a:t>Logika Alur: Percabangan &amp; Perulangan </a:t>
             </a:r>
             <a:r>
               <a:rPr sz="2100" b="1">
@@ -16683,7 +16683,7 @@
                 </a:solidFill>
                 <a:latin typeface="Plus Jakarta Sans"/>
               </a:rPr>
-              <a:t>Percabangan &amp; Iterasi</a:t>
+              <a:t>IF, CASE, WHILE &amp; LOOP</a:t>
             </a:r>
           </a:p>
         </p:txBody>
@@ -19343,7 +19343,7 @@
                 </a:solidFill>
                 <a:latin typeface="Plus Jakarta Sans"/>
               </a:rPr>
-              <a:t>Pengolahan Baris Tunggal Menggunakan CURSOR </a:t>
+              <a:t>Cursor: Memproses Data Baris demi Baris </a:t>
             </a:r>
             <a:r>
               <a:rPr sz="2100" b="1">
@@ -19352,7 +19352,7 @@
                 </a:solidFill>
                 <a:latin typeface="Plus Jakarta Sans"/>
               </a:rPr>
-              <a:t>Iterasi Sequential</a:t>
+              <a:t>5 Langkah Siklus</a:t>
             </a:r>
           </a:p>
         </p:txBody>
@@ -19492,7 +19492,7 @@
                 </a:solidFill>
                 <a:latin typeface="Inter"/>
               </a:rPr>
-              <a:t>Mendeklarasikan nama kursor dan kueri SELECT yang akan ditampung.</a:t>
+              <a:t>Mendeklarasikan nama kursor dan kueri SELECT yang akan dibaca.</a:t>
             </a:r>
           </a:p>
         </p:txBody>
@@ -19596,7 +19596,7 @@
                 </a:solidFill>
                 <a:latin typeface="Inter"/>
               </a:rPr>
-              <a:t>Mengeksekusi kueri SELECT dan menginisialisasi pointer data ke baris awal.</a:t>
+              <a:t>Mengeksekusi kueri SELECT dan menyiapkan pointer data di memori.</a:t>
             </a:r>
           </a:p>
         </p:txBody>
@@ -19700,7 +19700,7 @@
                 </a:solidFill>
                 <a:latin typeface="Inter"/>
               </a:rPr>
-              <a:t>Mengambil nilai kolom baris aktif ke variabel lokal dan menggeser pointer.</a:t>
+              <a:t>Mengambil nilai satu baris ke variabel lokal dan menggeser pointer.</a:t>
             </a:r>
           </a:p>
         </p:txBody>
@@ -19804,7 +19804,7 @@
                 </a:solidFill>
                 <a:latin typeface="Inter"/>
               </a:rPr>
-              <a:t>Menutup kursor dan membebaskan alokasi memori buffer RDBMS.</a:t>
+              <a:t>Menutup kursor dan membebaskan alokasi memori buffer server.</a:t>
             </a:r>
           </a:p>
         </p:txBody>
@@ -21382,7 +21382,7 @@
               </a:defRPr>
             </a:pPr>
             <a:r>
-              <a:t>● 07 · ERROR HANDLING</a:t>
+              <a:t>● 07 · PENANGANAN ERROR</a:t>
             </a:r>
           </a:p>
         </p:txBody>
@@ -21418,7 +21418,7 @@
               </a:defRPr>
             </a:pPr>
             <a:r>
-              <a:t>Manajemen Galat</a:t>
+              <a:t>Mencegah Data Selisih</a:t>
             </a:r>
           </a:p>
         </p:txBody>
@@ -21452,7 +21452,7 @@
                 </a:solidFill>
                 <a:latin typeface="Plus Jakarta Sans"/>
               </a:rPr>
-              <a:t>Penanganan Galat Terstruktur &amp; Integritas Transaksi </a:t>
+              <a:t>Error Handling: Menjaga Transaksi Tetap Aman </a:t>
             </a:r>
             <a:r>
               <a:rPr sz="2100" b="1">

</xml_diff>